<commit_message>
Pass raw_image to OCR to prevent heavy resolution degradation during license plate reading
</commit_message>
<xml_diff>
--- a/Gridlock_Pitch_Deck.pptx
+++ b/Gridlock_Pitch_Deck.pptx
@@ -11,6 +11,7 @@
     <p:sldId id="259" r:id="rId5"/>
     <p:sldId id="260" r:id="rId6"/>
     <p:sldId id="261" r:id="rId7"/>
+    <p:sldId id="262" r:id="rId12"/>
   </p:sldIdLst>
   <p:sldSz cx="9144000" cy="6858000" type="screen4x3"/>
   <p:notesSz cx="6858000" cy="9144000"/>
@@ -17731,6 +17732,90 @@
 </p:sld>
 </file>
 
+<file path=ppt/slides/slide7.xml><?xml version="1.0" encoding="utf-8"?>
+<p:sld xmlns:a="http://schemas.openxmlformats.org/drawingml/2006/main" xmlns:p="http://schemas.openxmlformats.org/presentationml/2006/main" xmlns:r="http://schemas.openxmlformats.org/officeDocument/2006/relationships">
+  <p:cSld>
+    <p:spTree>
+      <p:nvGrpSpPr>
+        <p:cNvPr id="1" name=""/>
+        <p:cNvGrpSpPr/>
+        <p:nvPr/>
+      </p:nvGrpSpPr>
+      <p:grpSpPr/>
+      <p:sp>
+        <p:nvSpPr>
+          <p:cNvPr id="2" name="Title 1"/>
+          <p:cNvSpPr>
+            <a:spLocks noGrp="1"/>
+          </p:cNvSpPr>
+          <p:nvPr>
+            <p:ph type="title"/>
+          </p:nvPr>
+        </p:nvSpPr>
+        <p:spPr/>
+        <p:txBody>
+          <a:bodyPr/>
+          <a:lstStyle/>
+          <a:p>
+            <a:r>
+              <a:t>Future Scope &amp; Expansion</a:t>
+            </a:r>
+          </a:p>
+        </p:txBody>
+      </p:sp>
+      <p:sp>
+        <p:nvSpPr>
+          <p:cNvPr id="3" name="Content Placeholder 2"/>
+          <p:cNvSpPr>
+            <a:spLocks noGrp="1"/>
+          </p:cNvSpPr>
+          <p:nvPr>
+            <p:ph idx="1"/>
+          </p:nvPr>
+        </p:nvSpPr>
+        <p:spPr/>
+        <p:txBody>
+          <a:bodyPr/>
+          <a:lstStyle/>
+          <a:p>
+            <a:r>
+              <a:t>Our architecture is built to scale far beyond a hackathon prototype:</a:t>
+            </a:r>
+          </a:p>
+          <a:p>
+            <a:pPr lvl="1"/>
+            <a:r>
+              <a:t>Pan-Tilt-Zoom (PTZ) Camera Integration: Dynamic tracking of offenders across multiple city intersections.</a:t>
+            </a:r>
+          </a:p>
+          <a:p>
+            <a:pPr lvl="1"/>
+            <a:r>
+              <a:t>Automated e-Challan Issuance: Direct integration with Regional Transport Office (RTO) APIs to automatically text/email fines to registered vehicle owners.</a:t>
+            </a:r>
+          </a:p>
+          <a:p>
+            <a:pPr lvl="1"/>
+            <a:r>
+              <a:t>Night Vision &amp; IR Optimization: Upgrading the Pre-processing layer (CLAHE) to handle Infrared camera feeds for 24/7 enforcement.</a:t>
+            </a:r>
+          </a:p>
+          <a:p>
+            <a:pPr lvl="1"/>
+            <a:r>
+              <a:t>Vehicle Make &amp; Model Classification: Adding a secondary model to detect the color and brand of the vehicle to catch stolen/fake license plates.</a:t>
+            </a:r>
+          </a:p>
+        </p:txBody>
+      </p:sp>
+    </p:spTree>
+  </p:cSld>
+  <p:clrMapOvr>
+    <a:masterClrMapping/>
+  </p:clrMapOvr>
+</p:sld>
+</file>
+
 <file path=ppt/theme/theme1.xml><?xml version="1.0" encoding="utf-8"?>
 <a:theme xmlns:a="http://schemas.openxmlformats.org/drawingml/2006/main" name="Retrospect">
   <a:themeElements>

</xml_diff>

<commit_message>
Add alphanumeric allowlist to EasyOCR to drastically improve license plate reading accuracy and prevent symbol hallucinations
</commit_message>
<xml_diff>
--- a/Gridlock_Pitch_Deck.pptx
+++ b/Gridlock_Pitch_Deck.pptx
@@ -11,7 +11,6 @@
     <p:sldId id="259" r:id="rId5"/>
     <p:sldId id="260" r:id="rId6"/>
     <p:sldId id="261" r:id="rId7"/>
-    <p:sldId id="262" r:id="rId12"/>
   </p:sldIdLst>
   <p:sldSz cx="9144000" cy="6858000" type="screen4x3"/>
   <p:notesSz cx="6858000" cy="9144000"/>
@@ -12652,7 +12651,7 @@
           <a:p>
             <a:fld id="{5BCAD085-E8A6-8845-BD4E-CB4CCA059FC4}" type="datetimeFigureOut">
               <a:rPr lang="en-US" smtClean="0"/>
-              <a:t>6/21/2026</a:t>
+              <a:t>6/22/2026</a:t>
             </a:fld>
             <a:endParaRPr lang="en-US"/>
           </a:p>
@@ -12860,7 +12859,7 @@
           <a:p>
             <a:fld id="{5BCAD085-E8A6-8845-BD4E-CB4CCA059FC4}" type="datetimeFigureOut">
               <a:rPr lang="en-US" smtClean="0"/>
-              <a:t>6/21/2026</a:t>
+              <a:t>6/22/2026</a:t>
             </a:fld>
             <a:endParaRPr lang="en-US"/>
           </a:p>
@@ -13116,7 +13115,7 @@
           <a:p>
             <a:fld id="{5BCAD085-E8A6-8845-BD4E-CB4CCA059FC4}" type="datetimeFigureOut">
               <a:rPr lang="en-US" smtClean="0"/>
-              <a:t>6/21/2026</a:t>
+              <a:t>6/22/2026</a:t>
             </a:fld>
             <a:endParaRPr lang="en-US"/>
           </a:p>
@@ -13286,7 +13285,7 @@
           <a:p>
             <a:fld id="{5BCAD085-E8A6-8845-BD4E-CB4CCA059FC4}" type="datetimeFigureOut">
               <a:rPr lang="en-US" smtClean="0"/>
-              <a:t>6/21/2026</a:t>
+              <a:t>6/22/2026</a:t>
             </a:fld>
             <a:endParaRPr lang="en-US"/>
           </a:p>
@@ -13629,7 +13628,7 @@
           <a:p>
             <a:fld id="{5BCAD085-E8A6-8845-BD4E-CB4CCA059FC4}" type="datetimeFigureOut">
               <a:rPr lang="en-US" smtClean="0"/>
-              <a:t>6/21/2026</a:t>
+              <a:t>6/22/2026</a:t>
             </a:fld>
             <a:endParaRPr lang="en-US"/>
           </a:p>
@@ -13904,7 +13903,7 @@
           <a:p>
             <a:fld id="{5BCAD085-E8A6-8845-BD4E-CB4CCA059FC4}" type="datetimeFigureOut">
               <a:rPr lang="en-US" smtClean="0"/>
-              <a:t>6/21/2026</a:t>
+              <a:t>6/22/2026</a:t>
             </a:fld>
             <a:endParaRPr lang="en-US"/>
           </a:p>
@@ -14283,7 +14282,7 @@
           <a:p>
             <a:fld id="{5BCAD085-E8A6-8845-BD4E-CB4CCA059FC4}" type="datetimeFigureOut">
               <a:rPr lang="en-US" smtClean="0"/>
-              <a:t>6/21/2026</a:t>
+              <a:t>6/22/2026</a:t>
             </a:fld>
             <a:endParaRPr lang="en-US"/>
           </a:p>
@@ -14401,7 +14400,7 @@
           <a:p>
             <a:fld id="{5BCAD085-E8A6-8845-BD4E-CB4CCA059FC4}" type="datetimeFigureOut">
               <a:rPr lang="en-US" smtClean="0"/>
-              <a:t>6/21/2026</a:t>
+              <a:t>6/22/2026</a:t>
             </a:fld>
             <a:endParaRPr lang="en-US"/>
           </a:p>
@@ -14572,7 +14571,7 @@
           <a:p>
             <a:fld id="{5BCAD085-E8A6-8845-BD4E-CB4CCA059FC4}" type="datetimeFigureOut">
               <a:rPr lang="en-US" smtClean="0"/>
-              <a:t>6/21/2026</a:t>
+              <a:t>6/22/2026</a:t>
             </a:fld>
             <a:endParaRPr lang="en-US"/>
           </a:p>
@@ -14926,7 +14925,7 @@
           <a:p>
             <a:fld id="{5BCAD085-E8A6-8845-BD4E-CB4CCA059FC4}" type="datetimeFigureOut">
               <a:rPr lang="en-US" smtClean="0"/>
-              <a:t>6/21/2026</a:t>
+              <a:t>6/22/2026</a:t>
             </a:fld>
             <a:endParaRPr lang="en-US"/>
           </a:p>
@@ -15308,7 +15307,7 @@
           <a:p>
             <a:fld id="{5BCAD085-E8A6-8845-BD4E-CB4CCA059FC4}" type="datetimeFigureOut">
               <a:rPr lang="en-US" smtClean="0"/>
-              <a:t>6/21/2026</a:t>
+              <a:t>6/22/2026</a:t>
             </a:fld>
             <a:endParaRPr lang="en-US"/>
           </a:p>
@@ -15595,7 +15594,7 @@
           <a:p>
             <a:fld id="{5BCAD085-E8A6-8845-BD4E-CB4CCA059FC4}" type="datetimeFigureOut">
               <a:rPr lang="en-US" smtClean="0"/>
-              <a:t>6/21/2026</a:t>
+              <a:t>6/22/2026</a:t>
             </a:fld>
             <a:endParaRPr lang="en-US"/>
           </a:p>
@@ -17732,90 +17731,6 @@
 </p:sld>
 </file>
 
-<file path=ppt/slides/slide7.xml><?xml version="1.0" encoding="utf-8"?>
-<p:sld xmlns:a="http://schemas.openxmlformats.org/drawingml/2006/main" xmlns:p="http://schemas.openxmlformats.org/presentationml/2006/main" xmlns:r="http://schemas.openxmlformats.org/officeDocument/2006/relationships">
-  <p:cSld>
-    <p:spTree>
-      <p:nvGrpSpPr>
-        <p:cNvPr id="1" name=""/>
-        <p:cNvGrpSpPr/>
-        <p:nvPr/>
-      </p:nvGrpSpPr>
-      <p:grpSpPr/>
-      <p:sp>
-        <p:nvSpPr>
-          <p:cNvPr id="2" name="Title 1"/>
-          <p:cNvSpPr>
-            <a:spLocks noGrp="1"/>
-          </p:cNvSpPr>
-          <p:nvPr>
-            <p:ph type="title"/>
-          </p:nvPr>
-        </p:nvSpPr>
-        <p:spPr/>
-        <p:txBody>
-          <a:bodyPr/>
-          <a:lstStyle/>
-          <a:p>
-            <a:r>
-              <a:t>Future Scope &amp; Expansion</a:t>
-            </a:r>
-          </a:p>
-        </p:txBody>
-      </p:sp>
-      <p:sp>
-        <p:nvSpPr>
-          <p:cNvPr id="3" name="Content Placeholder 2"/>
-          <p:cNvSpPr>
-            <a:spLocks noGrp="1"/>
-          </p:cNvSpPr>
-          <p:nvPr>
-            <p:ph idx="1"/>
-          </p:nvPr>
-        </p:nvSpPr>
-        <p:spPr/>
-        <p:txBody>
-          <a:bodyPr/>
-          <a:lstStyle/>
-          <a:p>
-            <a:r>
-              <a:t>Our architecture is built to scale far beyond a hackathon prototype:</a:t>
-            </a:r>
-          </a:p>
-          <a:p>
-            <a:pPr lvl="1"/>
-            <a:r>
-              <a:t>Pan-Tilt-Zoom (PTZ) Camera Integration: Dynamic tracking of offenders across multiple city intersections.</a:t>
-            </a:r>
-          </a:p>
-          <a:p>
-            <a:pPr lvl="1"/>
-            <a:r>
-              <a:t>Automated e-Challan Issuance: Direct integration with Regional Transport Office (RTO) APIs to automatically text/email fines to registered vehicle owners.</a:t>
-            </a:r>
-          </a:p>
-          <a:p>
-            <a:pPr lvl="1"/>
-            <a:r>
-              <a:t>Night Vision &amp; IR Optimization: Upgrading the Pre-processing layer (CLAHE) to handle Infrared camera feeds for 24/7 enforcement.</a:t>
-            </a:r>
-          </a:p>
-          <a:p>
-            <a:pPr lvl="1"/>
-            <a:r>
-              <a:t>Vehicle Make &amp; Model Classification: Adding a secondary model to detect the color and brand of the vehicle to catch stolen/fake license plates.</a:t>
-            </a:r>
-          </a:p>
-        </p:txBody>
-      </p:sp>
-    </p:spTree>
-  </p:cSld>
-  <p:clrMapOvr>
-    <a:masterClrMapping/>
-  </p:clrMapOvr>
-</p:sld>
-</file>
-
 <file path=ppt/theme/theme1.xml><?xml version="1.0" encoding="utf-8"?>
 <a:theme xmlns:a="http://schemas.openxmlformats.org/drawingml/2006/main" name="Retrospect">
   <a:themeElements>

</xml_diff>